<commit_message>
Decks: team name FireOrbit, full comparison slide in extended deck
Co-Authored-By: Claude Opus 5 <noreply@anthropic.com>
</commit_message>
<xml_diff>
--- a/docs/SIH26162_ThermalSentinel_Idea_6slides.pptx
+++ b/docs/SIH26162_ThermalSentinel_Idea_6slides.pptx
@@ -1642,7 +1642,7 @@
                 <a:ea typeface="Calibri" pitchFamily="34" charset="-122"/>
                 <a:cs typeface="Calibri" pitchFamily="34" charset="-120"/>
               </a:rPr>
-              <a:t>&lt;TEAM NAME&gt;</a:t>
+              <a:t>FireOrbit</a:t>
             </a:r>
             <a:endParaRPr lang="en-US" sz="1150" dirty="0"/>
           </a:p>
@@ -1894,7 +1894,7 @@
                 <a:ea typeface="Calibri" pitchFamily="34" charset="-122"/>
                 <a:cs typeface="Calibri" pitchFamily="34" charset="-120"/>
               </a:rPr>
-              <a:t>&lt;TEAM NAME&gt;</a:t>
+              <a:t>FireOrbit</a:t>
             </a:r>
             <a:endParaRPr lang="en-US" sz="900" dirty="0"/>
           </a:p>
@@ -4795,7 +4795,7 @@
                 <a:ea typeface="Calibri" pitchFamily="34" charset="-122"/>
                 <a:cs typeface="Calibri" pitchFamily="34" charset="-120"/>
               </a:rPr>
-              <a:t>&lt;TEAM NAME&gt;</a:t>
+              <a:t>FireOrbit</a:t>
             </a:r>
             <a:endParaRPr lang="en-US" sz="900" dirty="0"/>
           </a:p>
@@ -6692,7 +6692,7 @@
                 <a:ea typeface="Calibri" pitchFamily="34" charset="-122"/>
                 <a:cs typeface="Calibri" pitchFamily="34" charset="-120"/>
               </a:rPr>
-              <a:t>&lt;TEAM NAME&gt;</a:t>
+              <a:t>FireOrbit</a:t>
             </a:r>
             <a:endParaRPr lang="en-US" sz="900" dirty="0"/>
           </a:p>
@@ -7993,7 +7993,7 @@
                 <a:ea typeface="Calibri" pitchFamily="34" charset="-122"/>
                 <a:cs typeface="Calibri" pitchFamily="34" charset="-120"/>
               </a:rPr>
-              <a:t>&lt;TEAM NAME&gt;</a:t>
+              <a:t>FireOrbit</a:t>
             </a:r>
             <a:endParaRPr lang="en-US" sz="900" dirty="0"/>
           </a:p>
@@ -9113,7 +9113,7 @@
                 <a:ea typeface="Calibri" pitchFamily="34" charset="-122"/>
                 <a:cs typeface="Calibri" pitchFamily="34" charset="-120"/>
               </a:rPr>
-              <a:t>&lt;TEAM NAME&gt;</a:t>
+              <a:t>FireOrbit</a:t>
             </a:r>
             <a:endParaRPr lang="en-US" sz="900" dirty="0"/>
           </a:p>

</xml_diff>